<commit_message>
fix(slides): update ablation numbers after aspect-hybrid-features merge
reports/aspect_hybrid_ablation.csv changed in PR #7 (feature/aspect-hybrid-features):
Text+Lexicon CV Macro F1 0.5658 -> 0.5664 and Recall Negative 48.2% -> 48.0%.
Rebuild the deck so slide 6's stat chips match the current report numbers.
</commit_message>
<xml_diff>
--- a/reports/slides/NLP_ITviec_Sentiment_Slides.pptx
+++ b/reports/slides/NLP_ITviec_Sentiment_Slides.pptx
@@ -24759,7 +24759,7 @@
                 </a:solidFill>
                 <a:latin typeface="Segoe UI"/>
               </a:rPr>
-              <a:t>0.5579 → 0.5658</a:t>
+              <a:t>0.5579 → 0.5664</a:t>
             </a:r>
           </a:p>
         </p:txBody>
@@ -24899,7 +24899,7 @@
                 </a:solidFill>
                 <a:latin typeface="Segoe UI"/>
               </a:rPr>
-              <a:t>45.6% → 48.2%</a:t>
+              <a:t>45.6% → 48.0%</a:t>
             </a:r>
           </a:p>
         </p:txBody>

</xml_diff>